<commit_message>
LRT poster: real redesign — colored header bands + white cards
Replace flat "colored text on tinted card" section headers with solid colored
header bands (orange/red/blue) and white bold titles on clean white cards;
LRT accent title fits one line; top navy bar. All 19 icon/logo images and the
completed Kazakh translation preserved. Rendered previews added.

Co-Authored-By: Claude Opus 4.8 <noreply@anthropic.com>
Claude-Session: https://claude.ai/code/session_01Y4FYmWqoXUPooVmYjEXR6i
</commit_message>
<xml_diff>
--- a/lrt-poster/LRT_safety_poster_FINAL.pptx
+++ b/lrt-poster/LRT_safety_poster_FINAL.pptx
@@ -1021,7 +1021,7 @@
         <p:spPr>
           <a:xfrm>
             <a:off x="960120" y="384048"/>
-            <a:ext cx="5641848" cy="548640"/>
+            <a:ext cx="6096000" cy="548640"/>
           </a:xfrm>
           <a:prstGeom prst="rect">
             <a:avLst/>
@@ -1151,13 +1151,17 @@
           </a:xfrm>
           <a:prstGeom prst="roundRect">
             <a:avLst>
-              <a:gd name="adj" fmla="val 6000"/>
+              <a:gd name="adj" fmla="val 7000"/>
             </a:avLst>
           </a:prstGeom>
           <a:solidFill>
-            <a:srgbClr val="FCEEE8"/>
+            <a:srgbClr val="FFFFFF"/>
           </a:solidFill>
-          <a:ln/>
+          <a:ln w="12700">
+            <a:solidFill>
+              <a:srgbClr val="E5E9ED"/>
+            </a:solidFill>
+          </a:ln>
           <a:effectLst>
             <a:outerShdw sx="100000" sy="100000" kx="0" ky="0" algn="bl" rotWithShape="0" blurRad="101600" dist="38100" dir="5400000">
               <a:srgbClr val="0A2C40">
@@ -1169,22 +1173,68 @@
       </p:sp>
       <p:sp>
         <p:nvSpPr>
-          <p:cNvPr id="8" name="Shape 4"/>
-          <p:cNvSpPr/>
-          <p:nvPr/>
-        </p:nvSpPr>
-        <p:spPr>
-          <a:xfrm>
-            <a:off x="658368" y="1801368"/>
-            <a:ext cx="530352" cy="530352"/>
-          </a:xfrm>
-          <a:prstGeom prst="ellipse">
+          <p:cNvPr id="60" name="Rounded Rectangle 59"/>
+          <p:cNvSpPr/>
+          <p:nvPr/>
+        </p:nvSpPr>
+        <p:spPr>
+          <a:xfrm>
+            <a:off x="457200" y="1645920"/>
+            <a:ext cx="6647688" cy="635000"/>
+          </a:xfrm>
+          <a:prstGeom prst="roundRect">
             <a:avLst/>
           </a:prstGeom>
           <a:solidFill>
             <a:srgbClr val="E4572E"/>
           </a:solidFill>
-          <a:ln/>
+          <a:ln>
+            <a:noFill/>
+          </a:ln>
+          <a:effectLst/>
+        </p:spPr>
+        <p:style>
+          <a:lnRef idx="1">
+            <a:schemeClr val="accent1"/>
+          </a:lnRef>
+          <a:fillRef idx="3">
+            <a:schemeClr val="accent1"/>
+          </a:fillRef>
+          <a:effectRef idx="2">
+            <a:schemeClr val="accent1"/>
+          </a:effectRef>
+          <a:fontRef idx="minor">
+            <a:schemeClr val="lt1"/>
+          </a:fontRef>
+        </p:style>
+        <p:txBody>
+          <a:bodyPr rtlCol="0" anchor="ctr"/>
+          <a:lstStyle/>
+          <a:p>
+            <a:pPr algn="ctr"/>
+          </a:p>
+        </p:txBody>
+      </p:sp>
+      <p:sp>
+        <p:nvSpPr>
+          <p:cNvPr id="8" name="Shape 4"/>
+          <p:cNvSpPr/>
+          <p:nvPr/>
+        </p:nvSpPr>
+        <p:spPr>
+          <a:xfrm>
+            <a:off x="658368" y="1801368"/>
+            <a:ext cx="530352" cy="530352"/>
+          </a:xfrm>
+          <a:prstGeom prst="ellipse">
+            <a:avLst/>
+          </a:prstGeom>
+          <a:solidFill>
+            <a:srgbClr val="E4572E"/>
+          </a:solidFill>
+          <a:ln>
+            <a:noFill/>
+          </a:ln>
           <a:effectLst>
             <a:outerShdw sx="100000" sy="100000" kx="0" ky="0" algn="bl" rotWithShape="0" blurRad="76200" dist="25400" dir="5400000">
               <a:srgbClr val="0A2C40">
@@ -1245,7 +1295,7 @@
             <a:r>
               <a:rPr lang="en-US" sz="1600" b="1" dirty="0">
                 <a:solidFill>
-                  <a:srgbClr val="E4572E"/>
+                  <a:srgbClr val="FFFFFF"/>
                 </a:solidFill>
                 <a:latin typeface="Calibri" pitchFamily="34" charset="0"/>
                 <a:ea typeface="Calibri" pitchFamily="34" charset="-122"/>
@@ -1522,13 +1572,17 @@
           </a:xfrm>
           <a:prstGeom prst="roundRect">
             <a:avLst>
-              <a:gd name="adj" fmla="val 6000"/>
+              <a:gd name="adj" fmla="val 7000"/>
             </a:avLst>
           </a:prstGeom>
           <a:solidFill>
-            <a:srgbClr val="FBE7E1"/>
+            <a:srgbClr val="FFFFFF"/>
           </a:solidFill>
-          <a:ln/>
+          <a:ln w="12700">
+            <a:solidFill>
+              <a:srgbClr val="E5E9ED"/>
+            </a:solidFill>
+          </a:ln>
           <a:effectLst>
             <a:outerShdw sx="100000" sy="100000" kx="0" ky="0" algn="bl" rotWithShape="0" blurRad="101600" dist="38100" dir="5400000">
               <a:srgbClr val="0A2C40">
@@ -1540,22 +1594,68 @@
       </p:sp>
       <p:sp>
         <p:nvSpPr>
-          <p:cNvPr id="20" name="Shape 11"/>
-          <p:cNvSpPr/>
-          <p:nvPr/>
-        </p:nvSpPr>
-        <p:spPr>
-          <a:xfrm>
-            <a:off x="658368" y="4251960"/>
-            <a:ext cx="530352" cy="530352"/>
-          </a:xfrm>
-          <a:prstGeom prst="ellipse">
+          <p:cNvPr id="61" name="Rounded Rectangle 60"/>
+          <p:cNvSpPr/>
+          <p:nvPr/>
+        </p:nvSpPr>
+        <p:spPr>
+          <a:xfrm>
+            <a:off x="457200" y="4096512"/>
+            <a:ext cx="6647688" cy="635000"/>
+          </a:xfrm>
+          <a:prstGeom prst="roundRect">
             <a:avLst/>
           </a:prstGeom>
           <a:solidFill>
             <a:srgbClr val="C4321B"/>
           </a:solidFill>
-          <a:ln/>
+          <a:ln>
+            <a:noFill/>
+          </a:ln>
+          <a:effectLst/>
+        </p:spPr>
+        <p:style>
+          <a:lnRef idx="1">
+            <a:schemeClr val="accent1"/>
+          </a:lnRef>
+          <a:fillRef idx="3">
+            <a:schemeClr val="accent1"/>
+          </a:fillRef>
+          <a:effectRef idx="2">
+            <a:schemeClr val="accent1"/>
+          </a:effectRef>
+          <a:fontRef idx="minor">
+            <a:schemeClr val="lt1"/>
+          </a:fontRef>
+        </p:style>
+        <p:txBody>
+          <a:bodyPr rtlCol="0" anchor="ctr"/>
+          <a:lstStyle/>
+          <a:p>
+            <a:pPr algn="ctr"/>
+          </a:p>
+        </p:txBody>
+      </p:sp>
+      <p:sp>
+        <p:nvSpPr>
+          <p:cNvPr id="20" name="Shape 11"/>
+          <p:cNvSpPr/>
+          <p:nvPr/>
+        </p:nvSpPr>
+        <p:spPr>
+          <a:xfrm>
+            <a:off x="658368" y="4251960"/>
+            <a:ext cx="530352" cy="530352"/>
+          </a:xfrm>
+          <a:prstGeom prst="ellipse">
+            <a:avLst/>
+          </a:prstGeom>
+          <a:solidFill>
+            <a:srgbClr val="C4321B"/>
+          </a:solidFill>
+          <a:ln>
+            <a:noFill/>
+          </a:ln>
           <a:effectLst>
             <a:outerShdw sx="100000" sy="100000" kx="0" ky="0" algn="bl" rotWithShape="0" blurRad="76200" dist="25400" dir="5400000">
               <a:srgbClr val="0A2C40">
@@ -1616,7 +1716,7 @@
             <a:r>
               <a:rPr lang="en-US" sz="1600" b="1" dirty="0">
                 <a:solidFill>
-                  <a:srgbClr val="C4321B"/>
+                  <a:srgbClr val="FFFFFF"/>
                 </a:solidFill>
                 <a:latin typeface="Calibri" pitchFamily="34" charset="0"/>
                 <a:ea typeface="Calibri" pitchFamily="34" charset="-122"/>
@@ -1893,13 +1993,17 @@
           </a:xfrm>
           <a:prstGeom prst="roundRect">
             <a:avLst>
-              <a:gd name="adj" fmla="val 6000"/>
+              <a:gd name="adj" fmla="val 7000"/>
             </a:avLst>
           </a:prstGeom>
           <a:solidFill>
-            <a:srgbClr val="EAF6FC"/>
+            <a:srgbClr val="FFFFFF"/>
           </a:solidFill>
-          <a:ln/>
+          <a:ln w="12700">
+            <a:solidFill>
+              <a:srgbClr val="E5E9ED"/>
+            </a:solidFill>
+          </a:ln>
           <a:effectLst>
             <a:outerShdw sx="100000" sy="100000" kx="0" ky="0" algn="bl" rotWithShape="0" blurRad="101600" dist="38100" dir="5400000">
               <a:srgbClr val="0A2C40">
@@ -1911,22 +2015,68 @@
       </p:sp>
       <p:sp>
         <p:nvSpPr>
-          <p:cNvPr id="32" name="Shape 18"/>
-          <p:cNvSpPr/>
-          <p:nvPr/>
-        </p:nvSpPr>
-        <p:spPr>
-          <a:xfrm>
-            <a:off x="658368" y="6702552"/>
-            <a:ext cx="530352" cy="530352"/>
-          </a:xfrm>
-          <a:prstGeom prst="ellipse">
+          <p:cNvPr id="62" name="Rounded Rectangle 61"/>
+          <p:cNvSpPr/>
+          <p:nvPr/>
+        </p:nvSpPr>
+        <p:spPr>
+          <a:xfrm>
+            <a:off x="457200" y="6547104"/>
+            <a:ext cx="6647688" cy="635000"/>
+          </a:xfrm>
+          <a:prstGeom prst="roundRect">
             <a:avLst/>
           </a:prstGeom>
           <a:solidFill>
             <a:srgbClr val="0B5E86"/>
           </a:solidFill>
-          <a:ln/>
+          <a:ln>
+            <a:noFill/>
+          </a:ln>
+          <a:effectLst/>
+        </p:spPr>
+        <p:style>
+          <a:lnRef idx="1">
+            <a:schemeClr val="accent1"/>
+          </a:lnRef>
+          <a:fillRef idx="3">
+            <a:schemeClr val="accent1"/>
+          </a:fillRef>
+          <a:effectRef idx="2">
+            <a:schemeClr val="accent1"/>
+          </a:effectRef>
+          <a:fontRef idx="minor">
+            <a:schemeClr val="lt1"/>
+          </a:fontRef>
+        </p:style>
+        <p:txBody>
+          <a:bodyPr rtlCol="0" anchor="ctr"/>
+          <a:lstStyle/>
+          <a:p>
+            <a:pPr algn="ctr"/>
+          </a:p>
+        </p:txBody>
+      </p:sp>
+      <p:sp>
+        <p:nvSpPr>
+          <p:cNvPr id="32" name="Shape 18"/>
+          <p:cNvSpPr/>
+          <p:nvPr/>
+        </p:nvSpPr>
+        <p:spPr>
+          <a:xfrm>
+            <a:off x="658368" y="6702552"/>
+            <a:ext cx="530352" cy="530352"/>
+          </a:xfrm>
+          <a:prstGeom prst="ellipse">
+            <a:avLst/>
+          </a:prstGeom>
+          <a:solidFill>
+            <a:srgbClr val="0B5E86"/>
+          </a:solidFill>
+          <a:ln>
+            <a:noFill/>
+          </a:ln>
           <a:effectLst>
             <a:outerShdw sx="100000" sy="100000" kx="0" ky="0" algn="bl" rotWithShape="0" blurRad="76200" dist="25400" dir="5400000">
               <a:srgbClr val="0A2C40">
@@ -1987,7 +2137,7 @@
             <a:r>
               <a:rPr lang="en-US" sz="1600" b="1" dirty="0">
                 <a:solidFill>
-                  <a:srgbClr val="0B5E86"/>
+                  <a:srgbClr val="FFFFFF"/>
                 </a:solidFill>
                 <a:latin typeface="Calibri" pitchFamily="34" charset="0"/>
                 <a:ea typeface="Calibri" pitchFamily="34" charset="-122"/>
@@ -2814,7 +2964,7 @@
         <p:spPr>
           <a:xfrm>
             <a:off x="0" y="0"/>
-            <a:ext cx="7562088" cy="76200"/>
+            <a:ext cx="7562088" cy="88900"/>
           </a:xfrm>
           <a:prstGeom prst="rect">
             <a:avLst/>
@@ -2938,7 +3088,7 @@
         <p:spPr>
           <a:xfrm>
             <a:off x="960120" y="384048"/>
-            <a:ext cx="5641848" cy="548640"/>
+            <a:ext cx="6096000" cy="548640"/>
           </a:xfrm>
           <a:prstGeom prst="rect">
             <a:avLst/>
@@ -3068,13 +3218,17 @@
           </a:xfrm>
           <a:prstGeom prst="roundRect">
             <a:avLst>
-              <a:gd name="adj" fmla="val 6000"/>
+              <a:gd name="adj" fmla="val 7000"/>
             </a:avLst>
           </a:prstGeom>
           <a:solidFill>
-            <a:srgbClr val="FCEEE8"/>
+            <a:srgbClr val="FFFFFF"/>
           </a:solidFill>
-          <a:ln/>
+          <a:ln w="12700">
+            <a:solidFill>
+              <a:srgbClr val="E5E9ED"/>
+            </a:solidFill>
+          </a:ln>
           <a:effectLst>
             <a:outerShdw sx="100000" sy="100000" kx="0" ky="0" algn="bl" rotWithShape="0" blurRad="101600" dist="38100" dir="5400000">
               <a:srgbClr val="0A2C40">
@@ -3086,22 +3240,68 @@
       </p:sp>
       <p:sp>
         <p:nvSpPr>
-          <p:cNvPr id="8" name="Shape 4"/>
-          <p:cNvSpPr/>
-          <p:nvPr/>
-        </p:nvSpPr>
-        <p:spPr>
-          <a:xfrm>
-            <a:off x="658368" y="1801368"/>
-            <a:ext cx="530352" cy="530352"/>
-          </a:xfrm>
-          <a:prstGeom prst="ellipse">
+          <p:cNvPr id="60" name="Rounded Rectangle 59"/>
+          <p:cNvSpPr/>
+          <p:nvPr/>
+        </p:nvSpPr>
+        <p:spPr>
+          <a:xfrm>
+            <a:off x="457200" y="1645920"/>
+            <a:ext cx="6647688" cy="635000"/>
+          </a:xfrm>
+          <a:prstGeom prst="roundRect">
             <a:avLst/>
           </a:prstGeom>
           <a:solidFill>
             <a:srgbClr val="E4572E"/>
           </a:solidFill>
-          <a:ln/>
+          <a:ln>
+            <a:noFill/>
+          </a:ln>
+          <a:effectLst/>
+        </p:spPr>
+        <p:style>
+          <a:lnRef idx="1">
+            <a:schemeClr val="accent1"/>
+          </a:lnRef>
+          <a:fillRef idx="3">
+            <a:schemeClr val="accent1"/>
+          </a:fillRef>
+          <a:effectRef idx="2">
+            <a:schemeClr val="accent1"/>
+          </a:effectRef>
+          <a:fontRef idx="minor">
+            <a:schemeClr val="lt1"/>
+          </a:fontRef>
+        </p:style>
+        <p:txBody>
+          <a:bodyPr rtlCol="0" anchor="ctr"/>
+          <a:lstStyle/>
+          <a:p>
+            <a:pPr algn="ctr"/>
+          </a:p>
+        </p:txBody>
+      </p:sp>
+      <p:sp>
+        <p:nvSpPr>
+          <p:cNvPr id="8" name="Shape 4"/>
+          <p:cNvSpPr/>
+          <p:nvPr/>
+        </p:nvSpPr>
+        <p:spPr>
+          <a:xfrm>
+            <a:off x="658368" y="1801368"/>
+            <a:ext cx="530352" cy="530352"/>
+          </a:xfrm>
+          <a:prstGeom prst="ellipse">
+            <a:avLst/>
+          </a:prstGeom>
+          <a:solidFill>
+            <a:srgbClr val="E4572E"/>
+          </a:solidFill>
+          <a:ln>
+            <a:noFill/>
+          </a:ln>
           <a:effectLst>
             <a:outerShdw sx="100000" sy="100000" kx="0" ky="0" algn="bl" rotWithShape="0" blurRad="76200" dist="25400" dir="5400000">
               <a:srgbClr val="0A2C40">
@@ -3162,7 +3362,7 @@
             <a:r>
               <a:rPr lang="en-US" sz="1600" b="1" dirty="0">
                 <a:solidFill>
-                  <a:srgbClr val="E4572E"/>
+                  <a:srgbClr val="FFFFFF"/>
                 </a:solidFill>
                 <a:latin typeface="Calibri" pitchFamily="34" charset="0"/>
                 <a:ea typeface="Calibri" pitchFamily="34" charset="-122"/>
@@ -3439,13 +3639,17 @@
           </a:xfrm>
           <a:prstGeom prst="roundRect">
             <a:avLst>
-              <a:gd name="adj" fmla="val 6000"/>
+              <a:gd name="adj" fmla="val 7000"/>
             </a:avLst>
           </a:prstGeom>
           <a:solidFill>
-            <a:srgbClr val="FBE7E1"/>
+            <a:srgbClr val="FFFFFF"/>
           </a:solidFill>
-          <a:ln/>
+          <a:ln w="12700">
+            <a:solidFill>
+              <a:srgbClr val="E5E9ED"/>
+            </a:solidFill>
+          </a:ln>
           <a:effectLst>
             <a:outerShdw sx="100000" sy="100000" kx="0" ky="0" algn="bl" rotWithShape="0" blurRad="101600" dist="38100" dir="5400000">
               <a:srgbClr val="0A2C40">
@@ -3457,22 +3661,68 @@
       </p:sp>
       <p:sp>
         <p:nvSpPr>
-          <p:cNvPr id="20" name="Shape 11"/>
-          <p:cNvSpPr/>
-          <p:nvPr/>
-        </p:nvSpPr>
-        <p:spPr>
-          <a:xfrm>
-            <a:off x="658368" y="4251960"/>
-            <a:ext cx="530352" cy="530352"/>
-          </a:xfrm>
-          <a:prstGeom prst="ellipse">
+          <p:cNvPr id="61" name="Rounded Rectangle 60"/>
+          <p:cNvSpPr/>
+          <p:nvPr/>
+        </p:nvSpPr>
+        <p:spPr>
+          <a:xfrm>
+            <a:off x="457200" y="4096512"/>
+            <a:ext cx="6647688" cy="635000"/>
+          </a:xfrm>
+          <a:prstGeom prst="roundRect">
             <a:avLst/>
           </a:prstGeom>
           <a:solidFill>
             <a:srgbClr val="C4321B"/>
           </a:solidFill>
-          <a:ln/>
+          <a:ln>
+            <a:noFill/>
+          </a:ln>
+          <a:effectLst/>
+        </p:spPr>
+        <p:style>
+          <a:lnRef idx="1">
+            <a:schemeClr val="accent1"/>
+          </a:lnRef>
+          <a:fillRef idx="3">
+            <a:schemeClr val="accent1"/>
+          </a:fillRef>
+          <a:effectRef idx="2">
+            <a:schemeClr val="accent1"/>
+          </a:effectRef>
+          <a:fontRef idx="minor">
+            <a:schemeClr val="lt1"/>
+          </a:fontRef>
+        </p:style>
+        <p:txBody>
+          <a:bodyPr rtlCol="0" anchor="ctr"/>
+          <a:lstStyle/>
+          <a:p>
+            <a:pPr algn="ctr"/>
+          </a:p>
+        </p:txBody>
+      </p:sp>
+      <p:sp>
+        <p:nvSpPr>
+          <p:cNvPr id="20" name="Shape 11"/>
+          <p:cNvSpPr/>
+          <p:nvPr/>
+        </p:nvSpPr>
+        <p:spPr>
+          <a:xfrm>
+            <a:off x="658368" y="4251960"/>
+            <a:ext cx="530352" cy="530352"/>
+          </a:xfrm>
+          <a:prstGeom prst="ellipse">
+            <a:avLst/>
+          </a:prstGeom>
+          <a:solidFill>
+            <a:srgbClr val="C4321B"/>
+          </a:solidFill>
+          <a:ln>
+            <a:noFill/>
+          </a:ln>
           <a:effectLst>
             <a:outerShdw sx="100000" sy="100000" kx="0" ky="0" algn="bl" rotWithShape="0" blurRad="76200" dist="25400" dir="5400000">
               <a:srgbClr val="0A2C40">
@@ -3533,7 +3783,7 @@
             <a:r>
               <a:rPr lang="en-US" sz="1600" b="1" dirty="0">
                 <a:solidFill>
-                  <a:srgbClr val="C4321B"/>
+                  <a:srgbClr val="FFFFFF"/>
                 </a:solidFill>
                 <a:latin typeface="Calibri" pitchFamily="34" charset="0"/>
                 <a:ea typeface="Calibri" pitchFamily="34" charset="-122"/>
@@ -3810,13 +4060,17 @@
           </a:xfrm>
           <a:prstGeom prst="roundRect">
             <a:avLst>
-              <a:gd name="adj" fmla="val 6000"/>
+              <a:gd name="adj" fmla="val 7000"/>
             </a:avLst>
           </a:prstGeom>
           <a:solidFill>
-            <a:srgbClr val="EAF6FC"/>
+            <a:srgbClr val="FFFFFF"/>
           </a:solidFill>
-          <a:ln/>
+          <a:ln w="12700">
+            <a:solidFill>
+              <a:srgbClr val="E5E9ED"/>
+            </a:solidFill>
+          </a:ln>
           <a:effectLst>
             <a:outerShdw sx="100000" sy="100000" kx="0" ky="0" algn="bl" rotWithShape="0" blurRad="101600" dist="38100" dir="5400000">
               <a:srgbClr val="0A2C40">
@@ -3828,22 +4082,68 @@
       </p:sp>
       <p:sp>
         <p:nvSpPr>
-          <p:cNvPr id="32" name="Shape 18"/>
-          <p:cNvSpPr/>
-          <p:nvPr/>
-        </p:nvSpPr>
-        <p:spPr>
-          <a:xfrm>
-            <a:off x="658368" y="6702552"/>
-            <a:ext cx="530352" cy="530352"/>
-          </a:xfrm>
-          <a:prstGeom prst="ellipse">
+          <p:cNvPr id="62" name="Rounded Rectangle 61"/>
+          <p:cNvSpPr/>
+          <p:nvPr/>
+        </p:nvSpPr>
+        <p:spPr>
+          <a:xfrm>
+            <a:off x="457200" y="6547104"/>
+            <a:ext cx="6647688" cy="635000"/>
+          </a:xfrm>
+          <a:prstGeom prst="roundRect">
             <a:avLst/>
           </a:prstGeom>
           <a:solidFill>
             <a:srgbClr val="0B5E86"/>
           </a:solidFill>
-          <a:ln/>
+          <a:ln>
+            <a:noFill/>
+          </a:ln>
+          <a:effectLst/>
+        </p:spPr>
+        <p:style>
+          <a:lnRef idx="1">
+            <a:schemeClr val="accent1"/>
+          </a:lnRef>
+          <a:fillRef idx="3">
+            <a:schemeClr val="accent1"/>
+          </a:fillRef>
+          <a:effectRef idx="2">
+            <a:schemeClr val="accent1"/>
+          </a:effectRef>
+          <a:fontRef idx="minor">
+            <a:schemeClr val="lt1"/>
+          </a:fontRef>
+        </p:style>
+        <p:txBody>
+          <a:bodyPr rtlCol="0" anchor="ctr"/>
+          <a:lstStyle/>
+          <a:p>
+            <a:pPr algn="ctr"/>
+          </a:p>
+        </p:txBody>
+      </p:sp>
+      <p:sp>
+        <p:nvSpPr>
+          <p:cNvPr id="32" name="Shape 18"/>
+          <p:cNvSpPr/>
+          <p:nvPr/>
+        </p:nvSpPr>
+        <p:spPr>
+          <a:xfrm>
+            <a:off x="658368" y="6702552"/>
+            <a:ext cx="530352" cy="530352"/>
+          </a:xfrm>
+          <a:prstGeom prst="ellipse">
+            <a:avLst/>
+          </a:prstGeom>
+          <a:solidFill>
+            <a:srgbClr val="0B5E86"/>
+          </a:solidFill>
+          <a:ln>
+            <a:noFill/>
+          </a:ln>
           <a:effectLst>
             <a:outerShdw sx="100000" sy="100000" kx="0" ky="0" algn="bl" rotWithShape="0" blurRad="76200" dist="25400" dir="5400000">
               <a:srgbClr val="0A2C40">
@@ -3904,7 +4204,7 @@
             <a:r>
               <a:rPr lang="en-US" sz="1600" b="1" dirty="0">
                 <a:solidFill>
-                  <a:srgbClr val="0B5E86"/>
+                  <a:srgbClr val="FFFFFF"/>
                 </a:solidFill>
                 <a:latin typeface="Calibri" pitchFamily="34" charset="0"/>
                 <a:ea typeface="Calibri" pitchFamily="34" charset="-122"/>
@@ -4731,7 +5031,7 @@
         <p:spPr>
           <a:xfrm>
             <a:off x="0" y="0"/>
-            <a:ext cx="7562088" cy="76200"/>
+            <a:ext cx="7562088" cy="88900"/>
           </a:xfrm>
           <a:prstGeom prst="rect">
             <a:avLst/>

</xml_diff>

<commit_message>
LRT poster: bold poster redesign (navy gradient hero + numbered bands)
- Navy gradient hero with gold accent rule, white logo chips, big orange "LRT"
  wordmark, one-line title (RU + KZ), full-width subtitle/issuer
- Section blocks: clean white cards with solid colored header bands and large
  numbered badges (1/2/3)
- Kazakh translation completed; ЛРТ latinized to LRT
- Built with an in-repo approximate PPTX->PNG renderer (work/render.py) to
  design visually since LibreOffice can't run here; previews refreshed
</commit_message>
<xml_diff>
--- a/lrt-poster/LRT_safety_poster_FINAL.pptx
+++ b/lrt-poster/LRT_safety_poster_FINAL.pptx
@@ -964,6 +964,102 @@
           <a:chExt cx="0" cy="0"/>
         </a:xfrm>
       </p:grpSpPr>
+      <p:sp>
+        <p:nvSpPr>
+          <p:cNvPr id="59" name="Rectangle 58"/>
+          <p:cNvSpPr/>
+          <p:nvPr/>
+        </p:nvSpPr>
+        <p:spPr>
+          <a:xfrm>
+            <a:off x="0" y="0"/>
+            <a:ext cx="7562088" cy="1778000"/>
+          </a:xfrm>
+          <a:prstGeom prst="rect">
+            <a:avLst/>
+          </a:prstGeom>
+          <a:gradFill>
+            <a:gsLst>
+              <a:gs pos="0">
+                <a:srgbClr val="0E3A54"/>
+              </a:gs>
+              <a:gs pos="100000">
+                <a:srgbClr val="165A7C"/>
+              </a:gs>
+            </a:gsLst>
+            <a:lin ang="2700000" scaled="1"/>
+          </a:gradFill>
+          <a:ln>
+            <a:noFill/>
+          </a:ln>
+          <a:effectLst/>
+        </p:spPr>
+        <p:style>
+          <a:lnRef idx="1">
+            <a:schemeClr val="accent1"/>
+          </a:lnRef>
+          <a:fillRef idx="3">
+            <a:schemeClr val="accent1"/>
+          </a:fillRef>
+          <a:effectRef idx="2">
+            <a:schemeClr val="accent1"/>
+          </a:effectRef>
+          <a:fontRef idx="minor">
+            <a:schemeClr val="lt1"/>
+          </a:fontRef>
+        </p:style>
+        <p:txBody>
+          <a:bodyPr rtlCol="0" anchor="ctr"/>
+          <a:lstStyle/>
+          <a:p>
+            <a:pPr algn="ctr"/>
+          </a:p>
+        </p:txBody>
+      </p:sp>
+      <p:sp>
+        <p:nvSpPr>
+          <p:cNvPr id="61" name="Rounded Rectangle 60"/>
+          <p:cNvSpPr/>
+          <p:nvPr/>
+        </p:nvSpPr>
+        <p:spPr>
+          <a:xfrm>
+            <a:off x="381000" y="254000"/>
+            <a:ext cx="990600" cy="990600"/>
+          </a:xfrm>
+          <a:prstGeom prst="roundRect">
+            <a:avLst/>
+          </a:prstGeom>
+          <a:solidFill>
+            <a:srgbClr val="FFFFFF"/>
+          </a:solidFill>
+          <a:ln>
+            <a:noFill/>
+          </a:ln>
+          <a:effectLst/>
+        </p:spPr>
+        <p:style>
+          <a:lnRef idx="1">
+            <a:schemeClr val="accent1"/>
+          </a:lnRef>
+          <a:fillRef idx="3">
+            <a:schemeClr val="accent1"/>
+          </a:fillRef>
+          <a:effectRef idx="2">
+            <a:schemeClr val="accent1"/>
+          </a:effectRef>
+          <a:fontRef idx="minor">
+            <a:schemeClr val="lt1"/>
+          </a:fontRef>
+        </p:style>
+        <p:txBody>
+          <a:bodyPr rtlCol="0" anchor="ctr"/>
+          <a:lstStyle/>
+          <a:p>
+            <a:pPr algn="ctr"/>
+          </a:p>
+        </p:txBody>
+      </p:sp>
       <p:pic>
         <p:nvPicPr>
           <p:cNvPr id="2" name="Image 0" descr="/home/claude/emblem.png">    </p:cNvPr>
@@ -988,6 +1084,50 @@
           </a:prstGeom>
         </p:spPr>
       </p:pic>
+      <p:sp>
+        <p:nvSpPr>
+          <p:cNvPr id="62" name="Rounded Rectangle 61"/>
+          <p:cNvSpPr/>
+          <p:nvPr/>
+        </p:nvSpPr>
+        <p:spPr>
+          <a:xfrm>
+            <a:off x="5918200" y="304800"/>
+            <a:ext cx="1257300" cy="901700"/>
+          </a:xfrm>
+          <a:prstGeom prst="roundRect">
+            <a:avLst/>
+          </a:prstGeom>
+          <a:solidFill>
+            <a:srgbClr val="FFFFFF"/>
+          </a:solidFill>
+          <a:ln>
+            <a:noFill/>
+          </a:ln>
+          <a:effectLst/>
+        </p:spPr>
+        <p:style>
+          <a:lnRef idx="1">
+            <a:schemeClr val="accent1"/>
+          </a:lnRef>
+          <a:fillRef idx="3">
+            <a:schemeClr val="accent1"/>
+          </a:fillRef>
+          <a:effectRef idx="2">
+            <a:schemeClr val="accent1"/>
+          </a:effectRef>
+          <a:fontRef idx="minor">
+            <a:schemeClr val="lt1"/>
+          </a:fontRef>
+        </p:style>
+        <p:txBody>
+          <a:bodyPr rtlCol="0" anchor="ctr"/>
+          <a:lstStyle/>
+          <a:p>
+            <a:pPr algn="ctr"/>
+          </a:p>
+        </p:txBody>
+      </p:sp>
       <p:pic>
         <p:nvPicPr>
           <p:cNvPr id="3" name="Image 1" descr="/home/claude/zan_t.png">    </p:cNvPr>
@@ -1020,8 +1160,8 @@
         </p:nvSpPr>
         <p:spPr>
           <a:xfrm>
-            <a:off x="960120" y="384048"/>
-            <a:ext cx="6096000" cy="548640"/>
+            <a:off x="1498600" y="508000"/>
+            <a:ext cx="4470400" cy="381000"/>
           </a:xfrm>
           <a:prstGeom prst="rect">
             <a:avLst/>
@@ -1037,7 +1177,7 @@
               <a:buNone/>
             </a:pPr>
             <a:r>
-              <a:rPr lang="en-US" sz="2900" b="1" dirty="0">
+              <a:rPr lang="en-US" sz="2100" b="1" dirty="0">
                 <a:solidFill>
                   <a:srgbClr val="E4572E"/>
                 </a:solidFill>
@@ -1048,9 +1188,9 @@
               <a:t>LRT</a:t>
             </a:r>
             <a:r>
-              <a:rPr sz="2900" b="1">
-                <a:solidFill>
-                  <a:srgbClr val="0E3A54"/>
+              <a:rPr sz="2100" b="1">
+                <a:solidFill>
+                  <a:srgbClr val="FFFFFF"/>
                 </a:solidFill>
                 <a:latin typeface="Calibri"/>
               </a:rPr>
@@ -1068,8 +1208,8 @@
         </p:nvSpPr>
         <p:spPr>
           <a:xfrm>
-            <a:off x="822960" y="950976"/>
-            <a:ext cx="5916168" cy="457200"/>
+            <a:off x="457200" y="1270000"/>
+            <a:ext cx="6654800" cy="228600"/>
           </a:xfrm>
           <a:prstGeom prst="rect">
             <a:avLst/>
@@ -1085,9 +1225,9 @@
               <a:buNone/>
             </a:pPr>
             <a:r>
-              <a:rPr lang="en-US" sz="1300" dirty="0">
-                <a:solidFill>
-                  <a:srgbClr val="0B5E86"/>
+              <a:rPr lang="en-US" sz="1150" dirty="0">
+                <a:solidFill>
+                  <a:srgbClr val="C6D8E4"/>
                 </a:solidFill>
                 <a:latin typeface="Calibri" pitchFamily="34" charset="0"/>
                 <a:ea typeface="Calibri" pitchFamily="34" charset="-122"/>
@@ -1107,8 +1247,8 @@
         </p:nvSpPr>
         <p:spPr>
           <a:xfrm>
-            <a:off x="960120" y="1371600"/>
-            <a:ext cx="5641848" cy="256032"/>
+            <a:off x="457200" y="1511300"/>
+            <a:ext cx="6654800" cy="256032"/>
           </a:xfrm>
           <a:prstGeom prst="rect">
             <a:avLst/>
@@ -1126,7 +1266,7 @@
             <a:r>
               <a:rPr lang="en-US" sz="1200" i="1" dirty="0">
                 <a:solidFill>
-                  <a:srgbClr val="5A6B74"/>
+                  <a:srgbClr val="93ABBA"/>
                 </a:solidFill>
                 <a:latin typeface="Calibri" pitchFamily="34" charset="0"/>
                 <a:ea typeface="Calibri" pitchFamily="34" charset="-122"/>
@@ -1146,7 +1286,7 @@
         </p:nvSpPr>
         <p:spPr>
           <a:xfrm>
-            <a:off x="457200" y="1645920"/>
+            <a:off x="457200" y="1899920"/>
             <a:ext cx="6647688" cy="2322576"/>
           </a:xfrm>
           <a:prstGeom prst="roundRect">
@@ -1173,14 +1313,14 @@
       </p:sp>
       <p:sp>
         <p:nvSpPr>
-          <p:cNvPr id="60" name="Rounded Rectangle 59"/>
-          <p:cNvSpPr/>
-          <p:nvPr/>
-        </p:nvSpPr>
-        <p:spPr>
-          <a:xfrm>
-            <a:off x="457200" y="1645920"/>
-            <a:ext cx="6647688" cy="635000"/>
+          <p:cNvPr id="63" name="Rounded Rectangle 62"/>
+          <p:cNvSpPr/>
+          <p:nvPr/>
+        </p:nvSpPr>
+        <p:spPr>
+          <a:xfrm>
+            <a:off x="457200" y="1899920"/>
+            <a:ext cx="6647688" cy="660400"/>
           </a:xfrm>
           <a:prstGeom prst="roundRect">
             <a:avLst/>
@@ -1223,14 +1363,14 @@
         </p:nvSpPr>
         <p:spPr>
           <a:xfrm>
-            <a:off x="658368" y="1801368"/>
-            <a:ext cx="530352" cy="530352"/>
+            <a:off x="658368" y="2055368"/>
+            <a:ext cx="508000" cy="508000"/>
           </a:xfrm>
           <a:prstGeom prst="ellipse">
             <a:avLst/>
           </a:prstGeom>
           <a:solidFill>
-            <a:srgbClr val="E4572E"/>
+            <a:srgbClr val="FFFFFF"/>
           </a:solidFill>
           <a:ln>
             <a:noFill/>
@@ -1243,31 +1383,22 @@
             </a:outerShdw>
           </a:effectLst>
         </p:spPr>
-      </p:sp>
-      <p:pic>
-        <p:nvPicPr>
-          <p:cNvPr id="9" name="Image 2" descr="preencoded.png">    </p:cNvPr>
-          <p:cNvPicPr>
-            <a:picLocks noChangeAspect="1"/>
-          </p:cNvPicPr>
-          <p:nvPr/>
-        </p:nvPicPr>
-        <p:blipFill>
-          <a:blip r:embed="rId3"/>
-          <a:stretch>
-            <a:fillRect/>
-          </a:stretch>
-        </p:blipFill>
-        <p:spPr>
-          <a:xfrm>
-            <a:off x="785652" y="1928652"/>
-            <a:ext cx="275783" cy="275783"/>
-          </a:xfrm>
-          <a:prstGeom prst="rect">
-            <a:avLst/>
-          </a:prstGeom>
-        </p:spPr>
-      </p:pic>
+        <p:txBody>
+          <a:bodyPr wrap="none" anchor="ctr" lIns="0" rIns="0" tIns="0" bIns="0"/>
+          <a:p>
+            <a:pPr algn="ctr"/>
+            <a:r>
+              <a:rPr sz="2200" b="1">
+                <a:solidFill>
+                  <a:srgbClr val="E4572E"/>
+                </a:solidFill>
+                <a:latin typeface="Calibri"/>
+              </a:rPr>
+              <a:t>1</a:t>
+            </a:r>
+          </a:p>
+        </p:txBody>
+      </p:sp>
       <p:sp>
         <p:nvSpPr>
           <p:cNvPr id="10" name="Text 5"/>
@@ -1276,7 +1407,7 @@
         </p:nvSpPr>
         <p:spPr>
           <a:xfrm>
-            <a:off x="1325880" y="1801368"/>
+            <a:off x="1325880" y="2055368"/>
             <a:ext cx="5596128" cy="530352"/>
           </a:xfrm>
           <a:prstGeom prst="rect">
@@ -1323,7 +1454,7 @@
         </p:blipFill>
         <p:spPr>
           <a:xfrm>
-            <a:off x="749808" y="2404872"/>
+            <a:off x="749808" y="2658872"/>
             <a:ext cx="192024" cy="192024"/>
           </a:xfrm>
           <a:prstGeom prst="rect">
@@ -1339,7 +1470,7 @@
         </p:nvSpPr>
         <p:spPr>
           <a:xfrm>
-            <a:off x="1042416" y="2377440"/>
+            <a:off x="1042416" y="2631440"/>
             <a:ext cx="5779008" cy="365760"/>
           </a:xfrm>
           <a:prstGeom prst="rect">
@@ -1386,7 +1517,7 @@
         </p:blipFill>
         <p:spPr>
           <a:xfrm>
-            <a:off x="749808" y="2770632"/>
+            <a:off x="749808" y="3024632"/>
             <a:ext cx="192024" cy="192024"/>
           </a:xfrm>
           <a:prstGeom prst="rect">
@@ -1402,7 +1533,7 @@
         </p:nvSpPr>
         <p:spPr>
           <a:xfrm>
-            <a:off x="1042416" y="2743200"/>
+            <a:off x="1042416" y="2997200"/>
             <a:ext cx="5779008" cy="365760"/>
           </a:xfrm>
           <a:prstGeom prst="rect">
@@ -1449,7 +1580,7 @@
         </p:blipFill>
         <p:spPr>
           <a:xfrm>
-            <a:off x="749808" y="3136392"/>
+            <a:off x="749808" y="3390392"/>
             <a:ext cx="192024" cy="192024"/>
           </a:xfrm>
           <a:prstGeom prst="rect">
@@ -1465,7 +1596,7 @@
         </p:nvSpPr>
         <p:spPr>
           <a:xfrm>
-            <a:off x="1042416" y="3108960"/>
+            <a:off x="1042416" y="3362960"/>
             <a:ext cx="5779008" cy="365760"/>
           </a:xfrm>
           <a:prstGeom prst="rect">
@@ -1512,7 +1643,7 @@
         </p:blipFill>
         <p:spPr>
           <a:xfrm>
-            <a:off x="749808" y="3502152"/>
+            <a:off x="749808" y="3756152"/>
             <a:ext cx="192024" cy="192024"/>
           </a:xfrm>
           <a:prstGeom prst="rect">
@@ -1528,7 +1659,7 @@
         </p:nvSpPr>
         <p:spPr>
           <a:xfrm>
-            <a:off x="1042416" y="3474720"/>
+            <a:off x="1042416" y="3728720"/>
             <a:ext cx="5779008" cy="365760"/>
           </a:xfrm>
           <a:prstGeom prst="rect">
@@ -1567,7 +1698,7 @@
         </p:nvSpPr>
         <p:spPr>
           <a:xfrm>
-            <a:off x="457200" y="4096512"/>
+            <a:off x="457200" y="4350512"/>
             <a:ext cx="6647688" cy="2322576"/>
           </a:xfrm>
           <a:prstGeom prst="roundRect">
@@ -1594,14 +1725,14 @@
       </p:sp>
       <p:sp>
         <p:nvSpPr>
-          <p:cNvPr id="61" name="Rounded Rectangle 60"/>
-          <p:cNvSpPr/>
-          <p:nvPr/>
-        </p:nvSpPr>
-        <p:spPr>
-          <a:xfrm>
-            <a:off x="457200" y="4096512"/>
-            <a:ext cx="6647688" cy="635000"/>
+          <p:cNvPr id="64" name="Rounded Rectangle 63"/>
+          <p:cNvSpPr/>
+          <p:nvPr/>
+        </p:nvSpPr>
+        <p:spPr>
+          <a:xfrm>
+            <a:off x="457200" y="4350512"/>
+            <a:ext cx="6647688" cy="660400"/>
           </a:xfrm>
           <a:prstGeom prst="roundRect">
             <a:avLst/>
@@ -1644,14 +1775,14 @@
         </p:nvSpPr>
         <p:spPr>
           <a:xfrm>
-            <a:off x="658368" y="4251960"/>
-            <a:ext cx="530352" cy="530352"/>
+            <a:off x="658368" y="4505960"/>
+            <a:ext cx="508000" cy="508000"/>
           </a:xfrm>
           <a:prstGeom prst="ellipse">
             <a:avLst/>
           </a:prstGeom>
           <a:solidFill>
-            <a:srgbClr val="C4321B"/>
+            <a:srgbClr val="FFFFFF"/>
           </a:solidFill>
           <a:ln>
             <a:noFill/>
@@ -1664,31 +1795,22 @@
             </a:outerShdw>
           </a:effectLst>
         </p:spPr>
-      </p:sp>
-      <p:pic>
-        <p:nvPicPr>
-          <p:cNvPr id="21" name="Image 7" descr="preencoded.png">    </p:cNvPr>
-          <p:cNvPicPr>
-            <a:picLocks noChangeAspect="1"/>
-          </p:cNvPicPr>
-          <p:nvPr/>
-        </p:nvPicPr>
-        <p:blipFill>
-          <a:blip r:embed="rId8"/>
-          <a:stretch>
-            <a:fillRect/>
-          </a:stretch>
-        </p:blipFill>
-        <p:spPr>
-          <a:xfrm>
-            <a:off x="785652" y="4379244"/>
-            <a:ext cx="275783" cy="275783"/>
-          </a:xfrm>
-          <a:prstGeom prst="rect">
-            <a:avLst/>
-          </a:prstGeom>
-        </p:spPr>
-      </p:pic>
+        <p:txBody>
+          <a:bodyPr wrap="none" anchor="ctr" lIns="0" rIns="0" tIns="0" bIns="0"/>
+          <a:p>
+            <a:pPr algn="ctr"/>
+            <a:r>
+              <a:rPr sz="2200" b="1">
+                <a:solidFill>
+                  <a:srgbClr val="C4321B"/>
+                </a:solidFill>
+                <a:latin typeface="Calibri"/>
+              </a:rPr>
+              <a:t>2</a:t>
+            </a:r>
+          </a:p>
+        </p:txBody>
+      </p:sp>
       <p:sp>
         <p:nvSpPr>
           <p:cNvPr id="22" name="Text 12"/>
@@ -1697,7 +1819,7 @@
         </p:nvSpPr>
         <p:spPr>
           <a:xfrm>
-            <a:off x="1325880" y="4251960"/>
+            <a:off x="1325880" y="4505960"/>
             <a:ext cx="5596128" cy="530352"/>
           </a:xfrm>
           <a:prstGeom prst="rect">
@@ -1744,7 +1866,7 @@
         </p:blipFill>
         <p:spPr>
           <a:xfrm>
-            <a:off x="749808" y="4855464"/>
+            <a:off x="749808" y="5109464"/>
             <a:ext cx="192024" cy="192024"/>
           </a:xfrm>
           <a:prstGeom prst="rect">
@@ -1760,7 +1882,7 @@
         </p:nvSpPr>
         <p:spPr>
           <a:xfrm>
-            <a:off x="1042416" y="4828032"/>
+            <a:off x="1042416" y="5082032"/>
             <a:ext cx="5779008" cy="365760"/>
           </a:xfrm>
           <a:prstGeom prst="rect">
@@ -1807,7 +1929,7 @@
         </p:blipFill>
         <p:spPr>
           <a:xfrm>
-            <a:off x="749808" y="5221224"/>
+            <a:off x="749808" y="5475224"/>
             <a:ext cx="192024" cy="192024"/>
           </a:xfrm>
           <a:prstGeom prst="rect">
@@ -1823,7 +1945,7 @@
         </p:nvSpPr>
         <p:spPr>
           <a:xfrm>
-            <a:off x="1042416" y="5193792"/>
+            <a:off x="1042416" y="5447792"/>
             <a:ext cx="5779008" cy="365760"/>
           </a:xfrm>
           <a:prstGeom prst="rect">
@@ -1870,7 +1992,7 @@
         </p:blipFill>
         <p:spPr>
           <a:xfrm>
-            <a:off x="749808" y="5586984"/>
+            <a:off x="749808" y="5840984"/>
             <a:ext cx="192024" cy="192024"/>
           </a:xfrm>
           <a:prstGeom prst="rect">
@@ -1886,7 +2008,7 @@
         </p:nvSpPr>
         <p:spPr>
           <a:xfrm>
-            <a:off x="1042416" y="5559552"/>
+            <a:off x="1042416" y="5813552"/>
             <a:ext cx="5779008" cy="365760"/>
           </a:xfrm>
           <a:prstGeom prst="rect">
@@ -1933,7 +2055,7 @@
         </p:blipFill>
         <p:spPr>
           <a:xfrm>
-            <a:off x="749808" y="5952744"/>
+            <a:off x="749808" y="6206744"/>
             <a:ext cx="192024" cy="192024"/>
           </a:xfrm>
           <a:prstGeom prst="rect">
@@ -1949,7 +2071,7 @@
         </p:nvSpPr>
         <p:spPr>
           <a:xfrm>
-            <a:off x="1042416" y="5925312"/>
+            <a:off x="1042416" y="6179312"/>
             <a:ext cx="5779008" cy="365760"/>
           </a:xfrm>
           <a:prstGeom prst="rect">
@@ -1988,7 +2110,7 @@
         </p:nvSpPr>
         <p:spPr>
           <a:xfrm>
-            <a:off x="457200" y="6547104"/>
+            <a:off x="457200" y="6801104"/>
             <a:ext cx="6647688" cy="2121408"/>
           </a:xfrm>
           <a:prstGeom prst="roundRect">
@@ -2015,14 +2137,14 @@
       </p:sp>
       <p:sp>
         <p:nvSpPr>
-          <p:cNvPr id="62" name="Rounded Rectangle 61"/>
-          <p:cNvSpPr/>
-          <p:nvPr/>
-        </p:nvSpPr>
-        <p:spPr>
-          <a:xfrm>
-            <a:off x="457200" y="6547104"/>
-            <a:ext cx="6647688" cy="635000"/>
+          <p:cNvPr id="65" name="Rounded Rectangle 64"/>
+          <p:cNvSpPr/>
+          <p:nvPr/>
+        </p:nvSpPr>
+        <p:spPr>
+          <a:xfrm>
+            <a:off x="457200" y="6801104"/>
+            <a:ext cx="6647688" cy="660400"/>
           </a:xfrm>
           <a:prstGeom prst="roundRect">
             <a:avLst/>
@@ -2065,14 +2187,14 @@
         </p:nvSpPr>
         <p:spPr>
           <a:xfrm>
-            <a:off x="658368" y="6702552"/>
-            <a:ext cx="530352" cy="530352"/>
+            <a:off x="658368" y="6956552"/>
+            <a:ext cx="508000" cy="508000"/>
           </a:xfrm>
           <a:prstGeom prst="ellipse">
             <a:avLst/>
           </a:prstGeom>
           <a:solidFill>
-            <a:srgbClr val="0B5E86"/>
+            <a:srgbClr val="FFFFFF"/>
           </a:solidFill>
           <a:ln>
             <a:noFill/>
@@ -2085,31 +2207,22 @@
             </a:outerShdw>
           </a:effectLst>
         </p:spPr>
-      </p:sp>
-      <p:pic>
-        <p:nvPicPr>
-          <p:cNvPr id="33" name="Image 12" descr="preencoded.png">    </p:cNvPr>
-          <p:cNvPicPr>
-            <a:picLocks noChangeAspect="1"/>
-          </p:cNvPicPr>
-          <p:nvPr/>
-        </p:nvPicPr>
-        <p:blipFill>
-          <a:blip r:embed="rId13"/>
-          <a:stretch>
-            <a:fillRect/>
-          </a:stretch>
-        </p:blipFill>
-        <p:spPr>
-          <a:xfrm>
-            <a:off x="785652" y="6829836"/>
-            <a:ext cx="275783" cy="275783"/>
-          </a:xfrm>
-          <a:prstGeom prst="rect">
-            <a:avLst/>
-          </a:prstGeom>
-        </p:spPr>
-      </p:pic>
+        <p:txBody>
+          <a:bodyPr wrap="none" anchor="ctr" lIns="0" rIns="0" tIns="0" bIns="0"/>
+          <a:p>
+            <a:pPr algn="ctr"/>
+            <a:r>
+              <a:rPr sz="2200" b="1">
+                <a:solidFill>
+                  <a:srgbClr val="0B5E86"/>
+                </a:solidFill>
+                <a:latin typeface="Calibri"/>
+              </a:rPr>
+              <a:t>3</a:t>
+            </a:r>
+          </a:p>
+        </p:txBody>
+      </p:sp>
       <p:sp>
         <p:nvSpPr>
           <p:cNvPr id="34" name="Text 19"/>
@@ -2118,7 +2231,7 @@
         </p:nvSpPr>
         <p:spPr>
           <a:xfrm>
-            <a:off x="1325880" y="6702552"/>
+            <a:off x="1325880" y="6956552"/>
             <a:ext cx="5596128" cy="530352"/>
           </a:xfrm>
           <a:prstGeom prst="rect">
@@ -2165,7 +2278,7 @@
         </p:blipFill>
         <p:spPr>
           <a:xfrm>
-            <a:off x="731520" y="7306056"/>
+            <a:off x="731520" y="7560056"/>
             <a:ext cx="173736" cy="173736"/>
           </a:xfrm>
           <a:prstGeom prst="rect">
@@ -2181,7 +2294,7 @@
         </p:nvSpPr>
         <p:spPr>
           <a:xfrm>
-            <a:off x="987552" y="7278624"/>
+            <a:off x="987552" y="7532624"/>
             <a:ext cx="2729484" cy="420624"/>
           </a:xfrm>
           <a:prstGeom prst="rect">
@@ -2228,7 +2341,7 @@
         </p:blipFill>
         <p:spPr>
           <a:xfrm>
-            <a:off x="731520" y="7726680"/>
+            <a:off x="731520" y="7980680"/>
             <a:ext cx="173736" cy="173736"/>
           </a:xfrm>
           <a:prstGeom prst="rect">
@@ -2244,7 +2357,7 @@
         </p:nvSpPr>
         <p:spPr>
           <a:xfrm>
-            <a:off x="987552" y="7699248"/>
+            <a:off x="987552" y="7953248"/>
             <a:ext cx="2729484" cy="420624"/>
           </a:xfrm>
           <a:prstGeom prst="rect">
@@ -2291,7 +2404,7 @@
         </p:blipFill>
         <p:spPr>
           <a:xfrm>
-            <a:off x="731520" y="8147304"/>
+            <a:off x="731520" y="8401304"/>
             <a:ext cx="173736" cy="173736"/>
           </a:xfrm>
           <a:prstGeom prst="rect">
@@ -2307,7 +2420,7 @@
         </p:nvSpPr>
         <p:spPr>
           <a:xfrm>
-            <a:off x="987552" y="8119872"/>
+            <a:off x="987552" y="8373872"/>
             <a:ext cx="2729484" cy="420624"/>
           </a:xfrm>
           <a:prstGeom prst="rect">
@@ -2354,7 +2467,7 @@
         </p:blipFill>
         <p:spPr>
           <a:xfrm>
-            <a:off x="3826764" y="7306056"/>
+            <a:off x="3826764" y="7560056"/>
             <a:ext cx="173736" cy="173736"/>
           </a:xfrm>
           <a:prstGeom prst="rect">
@@ -2370,7 +2483,7 @@
         </p:nvSpPr>
         <p:spPr>
           <a:xfrm>
-            <a:off x="4082796" y="7278624"/>
+            <a:off x="4082796" y="7532624"/>
             <a:ext cx="2729484" cy="420624"/>
           </a:xfrm>
           <a:prstGeom prst="rect">
@@ -2417,7 +2530,7 @@
         </p:blipFill>
         <p:spPr>
           <a:xfrm>
-            <a:off x="3826764" y="7726680"/>
+            <a:off x="3826764" y="7980680"/>
             <a:ext cx="173736" cy="173736"/>
           </a:xfrm>
           <a:prstGeom prst="rect">
@@ -2433,7 +2546,7 @@
         </p:nvSpPr>
         <p:spPr>
           <a:xfrm>
-            <a:off x="4082796" y="7699248"/>
+            <a:off x="4082796" y="7953248"/>
             <a:ext cx="2729484" cy="420624"/>
           </a:xfrm>
           <a:prstGeom prst="rect">
@@ -2480,7 +2593,7 @@
         </p:blipFill>
         <p:spPr>
           <a:xfrm>
-            <a:off x="3826764" y="8147304"/>
+            <a:off x="3826764" y="8401304"/>
             <a:ext cx="173736" cy="173736"/>
           </a:xfrm>
           <a:prstGeom prst="rect">
@@ -2496,7 +2609,7 @@
         </p:nvSpPr>
         <p:spPr>
           <a:xfrm>
-            <a:off x="4082796" y="8119872"/>
+            <a:off x="4082796" y="8373872"/>
             <a:ext cx="2729484" cy="420624"/>
           </a:xfrm>
           <a:prstGeom prst="rect">
@@ -2535,7 +2648,7 @@
         </p:nvSpPr>
         <p:spPr>
           <a:xfrm>
-            <a:off x="457200" y="8796528"/>
+            <a:off x="457200" y="9050528"/>
             <a:ext cx="6647688" cy="274320"/>
           </a:xfrm>
           <a:prstGeom prst="rect">
@@ -2574,7 +2687,7 @@
         </p:nvSpPr>
         <p:spPr>
           <a:xfrm>
-            <a:off x="457200" y="9107424"/>
+            <a:off x="457200" y="9361424"/>
             <a:ext cx="2093976" cy="676656"/>
           </a:xfrm>
           <a:prstGeom prst="roundRect">
@@ -2603,7 +2716,7 @@
         </p:nvSpPr>
         <p:spPr>
           <a:xfrm>
-            <a:off x="548640" y="9107424"/>
+            <a:off x="548640" y="9361424"/>
             <a:ext cx="841248" cy="676656"/>
           </a:xfrm>
           <a:prstGeom prst="rect">
@@ -2642,7 +2755,7 @@
         </p:nvSpPr>
         <p:spPr>
           <a:xfrm>
-            <a:off x="1353312" y="9107424"/>
+            <a:off x="1353312" y="9361424"/>
             <a:ext cx="1124712" cy="676656"/>
           </a:xfrm>
           <a:prstGeom prst="rect">
@@ -2681,7 +2794,7 @@
         </p:nvSpPr>
         <p:spPr>
           <a:xfrm>
-            <a:off x="2734056" y="9107424"/>
+            <a:off x="2734056" y="9361424"/>
             <a:ext cx="2093976" cy="676656"/>
           </a:xfrm>
           <a:prstGeom prst="roundRect">
@@ -2710,7 +2823,7 @@
         </p:nvSpPr>
         <p:spPr>
           <a:xfrm>
-            <a:off x="2825496" y="9107424"/>
+            <a:off x="2825496" y="9361424"/>
             <a:ext cx="841248" cy="676656"/>
           </a:xfrm>
           <a:prstGeom prst="rect">
@@ -2749,7 +2862,7 @@
         </p:nvSpPr>
         <p:spPr>
           <a:xfrm>
-            <a:off x="3630168" y="9107424"/>
+            <a:off x="3630168" y="9361424"/>
             <a:ext cx="1124712" cy="676656"/>
           </a:xfrm>
           <a:prstGeom prst="rect">
@@ -2788,7 +2901,7 @@
         </p:nvSpPr>
         <p:spPr>
           <a:xfrm>
-            <a:off x="5010912" y="9107424"/>
+            <a:off x="5010912" y="9361424"/>
             <a:ext cx="2093976" cy="676656"/>
           </a:xfrm>
           <a:prstGeom prst="roundRect">
@@ -2817,7 +2930,7 @@
         </p:nvSpPr>
         <p:spPr>
           <a:xfrm>
-            <a:off x="5102352" y="9107424"/>
+            <a:off x="5102352" y="9361424"/>
             <a:ext cx="841248" cy="676656"/>
           </a:xfrm>
           <a:prstGeom prst="rect">
@@ -2856,7 +2969,7 @@
         </p:nvSpPr>
         <p:spPr>
           <a:xfrm>
-            <a:off x="5907024" y="9107424"/>
+            <a:off x="5907024" y="9361424"/>
             <a:ext cx="1124712" cy="676656"/>
           </a:xfrm>
           <a:prstGeom prst="rect">
@@ -2895,7 +3008,7 @@
         </p:nvSpPr>
         <p:spPr>
           <a:xfrm>
-            <a:off x="457200" y="9857232"/>
+            <a:off x="457200" y="10111232"/>
             <a:ext cx="6647688" cy="512064"/>
           </a:xfrm>
           <a:prstGeom prst="roundRect">
@@ -2924,7 +3037,7 @@
         </p:nvSpPr>
         <p:spPr>
           <a:xfrm>
-            <a:off x="640080" y="9857232"/>
+            <a:off x="640080" y="10111232"/>
             <a:ext cx="6281928" cy="512064"/>
           </a:xfrm>
           <a:prstGeom prst="rect">
@@ -2957,20 +3070,20 @@
       </p:sp>
       <p:sp>
         <p:nvSpPr>
-          <p:cNvPr id="59" name="Rectangle 58"/>
-          <p:cNvSpPr/>
-          <p:nvPr/>
-        </p:nvSpPr>
-        <p:spPr>
-          <a:xfrm>
-            <a:off x="0" y="0"/>
-            <a:ext cx="7562088" cy="88900"/>
+          <p:cNvPr id="60" name="Rectangle 59"/>
+          <p:cNvSpPr/>
+          <p:nvPr/>
+        </p:nvSpPr>
+        <p:spPr>
+          <a:xfrm>
+            <a:off x="0" y="1778000"/>
+            <a:ext cx="7562088" cy="63500"/>
           </a:xfrm>
           <a:prstGeom prst="rect">
             <a:avLst/>
           </a:prstGeom>
           <a:solidFill>
-            <a:srgbClr val="0E3A54"/>
+            <a:srgbClr val="FDB515"/>
           </a:solidFill>
           <a:ln>
             <a:noFill/>
@@ -3031,6 +3144,102 @@
           <a:chExt cx="0" cy="0"/>
         </a:xfrm>
       </p:grpSpPr>
+      <p:sp>
+        <p:nvSpPr>
+          <p:cNvPr id="59" name="Rectangle 58"/>
+          <p:cNvSpPr/>
+          <p:nvPr/>
+        </p:nvSpPr>
+        <p:spPr>
+          <a:xfrm>
+            <a:off x="0" y="0"/>
+            <a:ext cx="7562088" cy="1778000"/>
+          </a:xfrm>
+          <a:prstGeom prst="rect">
+            <a:avLst/>
+          </a:prstGeom>
+          <a:gradFill>
+            <a:gsLst>
+              <a:gs pos="0">
+                <a:srgbClr val="0E3A54"/>
+              </a:gs>
+              <a:gs pos="100000">
+                <a:srgbClr val="165A7C"/>
+              </a:gs>
+            </a:gsLst>
+            <a:lin ang="2700000" scaled="1"/>
+          </a:gradFill>
+          <a:ln>
+            <a:noFill/>
+          </a:ln>
+          <a:effectLst/>
+        </p:spPr>
+        <p:style>
+          <a:lnRef idx="1">
+            <a:schemeClr val="accent1"/>
+          </a:lnRef>
+          <a:fillRef idx="3">
+            <a:schemeClr val="accent1"/>
+          </a:fillRef>
+          <a:effectRef idx="2">
+            <a:schemeClr val="accent1"/>
+          </a:effectRef>
+          <a:fontRef idx="minor">
+            <a:schemeClr val="lt1"/>
+          </a:fontRef>
+        </p:style>
+        <p:txBody>
+          <a:bodyPr rtlCol="0" anchor="ctr"/>
+          <a:lstStyle/>
+          <a:p>
+            <a:pPr algn="ctr"/>
+          </a:p>
+        </p:txBody>
+      </p:sp>
+      <p:sp>
+        <p:nvSpPr>
+          <p:cNvPr id="61" name="Rounded Rectangle 60"/>
+          <p:cNvSpPr/>
+          <p:nvPr/>
+        </p:nvSpPr>
+        <p:spPr>
+          <a:xfrm>
+            <a:off x="381000" y="254000"/>
+            <a:ext cx="990600" cy="990600"/>
+          </a:xfrm>
+          <a:prstGeom prst="roundRect">
+            <a:avLst/>
+          </a:prstGeom>
+          <a:solidFill>
+            <a:srgbClr val="FFFFFF"/>
+          </a:solidFill>
+          <a:ln>
+            <a:noFill/>
+          </a:ln>
+          <a:effectLst/>
+        </p:spPr>
+        <p:style>
+          <a:lnRef idx="1">
+            <a:schemeClr val="accent1"/>
+          </a:lnRef>
+          <a:fillRef idx="3">
+            <a:schemeClr val="accent1"/>
+          </a:fillRef>
+          <a:effectRef idx="2">
+            <a:schemeClr val="accent1"/>
+          </a:effectRef>
+          <a:fontRef idx="minor">
+            <a:schemeClr val="lt1"/>
+          </a:fontRef>
+        </p:style>
+        <p:txBody>
+          <a:bodyPr rtlCol="0" anchor="ctr"/>
+          <a:lstStyle/>
+          <a:p>
+            <a:pPr algn="ctr"/>
+          </a:p>
+        </p:txBody>
+      </p:sp>
       <p:pic>
         <p:nvPicPr>
           <p:cNvPr id="2" name="Image 0" descr="/home/claude/emblem.png">    </p:cNvPr>
@@ -3055,6 +3264,50 @@
           </a:prstGeom>
         </p:spPr>
       </p:pic>
+      <p:sp>
+        <p:nvSpPr>
+          <p:cNvPr id="62" name="Rounded Rectangle 61"/>
+          <p:cNvSpPr/>
+          <p:nvPr/>
+        </p:nvSpPr>
+        <p:spPr>
+          <a:xfrm>
+            <a:off x="5918200" y="304800"/>
+            <a:ext cx="1257300" cy="901700"/>
+          </a:xfrm>
+          <a:prstGeom prst="roundRect">
+            <a:avLst/>
+          </a:prstGeom>
+          <a:solidFill>
+            <a:srgbClr val="FFFFFF"/>
+          </a:solidFill>
+          <a:ln>
+            <a:noFill/>
+          </a:ln>
+          <a:effectLst/>
+        </p:spPr>
+        <p:style>
+          <a:lnRef idx="1">
+            <a:schemeClr val="accent1"/>
+          </a:lnRef>
+          <a:fillRef idx="3">
+            <a:schemeClr val="accent1"/>
+          </a:fillRef>
+          <a:effectRef idx="2">
+            <a:schemeClr val="accent1"/>
+          </a:effectRef>
+          <a:fontRef idx="minor">
+            <a:schemeClr val="lt1"/>
+          </a:fontRef>
+        </p:style>
+        <p:txBody>
+          <a:bodyPr rtlCol="0" anchor="ctr"/>
+          <a:lstStyle/>
+          <a:p>
+            <a:pPr algn="ctr"/>
+          </a:p>
+        </p:txBody>
+      </p:sp>
       <p:pic>
         <p:nvPicPr>
           <p:cNvPr id="3" name="Image 1" descr="/home/claude/zan_t.png">    </p:cNvPr>
@@ -3087,8 +3340,8 @@
         </p:nvSpPr>
         <p:spPr>
           <a:xfrm>
-            <a:off x="960120" y="384048"/>
-            <a:ext cx="6096000" cy="548640"/>
+            <a:off x="1498600" y="508000"/>
+            <a:ext cx="4470400" cy="381000"/>
           </a:xfrm>
           <a:prstGeom prst="rect">
             <a:avLst/>
@@ -3104,7 +3357,7 @@
               <a:buNone/>
             </a:pPr>
             <a:r>
-              <a:rPr lang="en-US" sz="2900" b="1" dirty="0">
+              <a:rPr lang="en-US" sz="2100" b="1" dirty="0">
                 <a:solidFill>
                   <a:srgbClr val="E4572E"/>
                 </a:solidFill>
@@ -3115,9 +3368,9 @@
               <a:t>LRT</a:t>
             </a:r>
             <a:r>
-              <a:rPr sz="2900" b="1">
-                <a:solidFill>
-                  <a:srgbClr val="0E3A54"/>
+              <a:rPr sz="2100" b="1">
+                <a:solidFill>
+                  <a:srgbClr val="FFFFFF"/>
                 </a:solidFill>
                 <a:latin typeface="Calibri"/>
               </a:rPr>
@@ -3135,8 +3388,8 @@
         </p:nvSpPr>
         <p:spPr>
           <a:xfrm>
-            <a:off x="822960" y="950976"/>
-            <a:ext cx="5916168" cy="457200"/>
+            <a:off x="457200" y="1270000"/>
+            <a:ext cx="6654800" cy="228600"/>
           </a:xfrm>
           <a:prstGeom prst="rect">
             <a:avLst/>
@@ -3152,9 +3405,9 @@
               <a:buNone/>
             </a:pPr>
             <a:r>
-              <a:rPr lang="en-US" sz="1300" dirty="0">
-                <a:solidFill>
-                  <a:srgbClr val="0B5E86"/>
+              <a:rPr lang="en-US" sz="1150" dirty="0">
+                <a:solidFill>
+                  <a:srgbClr val="C6D8E4"/>
                 </a:solidFill>
                 <a:latin typeface="Calibri" pitchFamily="34" charset="0"/>
                 <a:ea typeface="Calibri" pitchFamily="34" charset="-122"/>
@@ -3174,8 +3427,8 @@
         </p:nvSpPr>
         <p:spPr>
           <a:xfrm>
-            <a:off x="960120" y="1371600"/>
-            <a:ext cx="5641848" cy="256032"/>
+            <a:off x="457200" y="1511300"/>
+            <a:ext cx="6654800" cy="256032"/>
           </a:xfrm>
           <a:prstGeom prst="rect">
             <a:avLst/>
@@ -3193,7 +3446,7 @@
             <a:r>
               <a:rPr lang="en-US" sz="1200" i="1" dirty="0">
                 <a:solidFill>
-                  <a:srgbClr val="5A6B74"/>
+                  <a:srgbClr val="93ABBA"/>
                 </a:solidFill>
                 <a:latin typeface="Calibri" pitchFamily="34" charset="0"/>
                 <a:ea typeface="Calibri" pitchFamily="34" charset="-122"/>
@@ -3213,7 +3466,7 @@
         </p:nvSpPr>
         <p:spPr>
           <a:xfrm>
-            <a:off x="457200" y="1645920"/>
+            <a:off x="457200" y="1899920"/>
             <a:ext cx="6647688" cy="2322576"/>
           </a:xfrm>
           <a:prstGeom prst="roundRect">
@@ -3240,14 +3493,14 @@
       </p:sp>
       <p:sp>
         <p:nvSpPr>
-          <p:cNvPr id="60" name="Rounded Rectangle 59"/>
-          <p:cNvSpPr/>
-          <p:nvPr/>
-        </p:nvSpPr>
-        <p:spPr>
-          <a:xfrm>
-            <a:off x="457200" y="1645920"/>
-            <a:ext cx="6647688" cy="635000"/>
+          <p:cNvPr id="63" name="Rounded Rectangle 62"/>
+          <p:cNvSpPr/>
+          <p:nvPr/>
+        </p:nvSpPr>
+        <p:spPr>
+          <a:xfrm>
+            <a:off x="457200" y="1899920"/>
+            <a:ext cx="6647688" cy="660400"/>
           </a:xfrm>
           <a:prstGeom prst="roundRect">
             <a:avLst/>
@@ -3290,14 +3543,14 @@
         </p:nvSpPr>
         <p:spPr>
           <a:xfrm>
-            <a:off x="658368" y="1801368"/>
-            <a:ext cx="530352" cy="530352"/>
+            <a:off x="658368" y="2055368"/>
+            <a:ext cx="508000" cy="508000"/>
           </a:xfrm>
           <a:prstGeom prst="ellipse">
             <a:avLst/>
           </a:prstGeom>
           <a:solidFill>
-            <a:srgbClr val="E4572E"/>
+            <a:srgbClr val="FFFFFF"/>
           </a:solidFill>
           <a:ln>
             <a:noFill/>
@@ -3310,31 +3563,22 @@
             </a:outerShdw>
           </a:effectLst>
         </p:spPr>
-      </p:sp>
-      <p:pic>
-        <p:nvPicPr>
-          <p:cNvPr id="9" name="Image 2" descr="preencoded.png">    </p:cNvPr>
-          <p:cNvPicPr>
-            <a:picLocks noChangeAspect="1"/>
-          </p:cNvPicPr>
-          <p:nvPr/>
-        </p:nvPicPr>
-        <p:blipFill>
-          <a:blip r:embed="rId3"/>
-          <a:stretch>
-            <a:fillRect/>
-          </a:stretch>
-        </p:blipFill>
-        <p:spPr>
-          <a:xfrm>
-            <a:off x="785652" y="1928652"/>
-            <a:ext cx="275783" cy="275783"/>
-          </a:xfrm>
-          <a:prstGeom prst="rect">
-            <a:avLst/>
-          </a:prstGeom>
-        </p:spPr>
-      </p:pic>
+        <p:txBody>
+          <a:bodyPr wrap="none" anchor="ctr" lIns="0" rIns="0" tIns="0" bIns="0"/>
+          <a:p>
+            <a:pPr algn="ctr"/>
+            <a:r>
+              <a:rPr sz="2200" b="1">
+                <a:solidFill>
+                  <a:srgbClr val="E4572E"/>
+                </a:solidFill>
+                <a:latin typeface="Calibri"/>
+              </a:rPr>
+              <a:t>1</a:t>
+            </a:r>
+          </a:p>
+        </p:txBody>
+      </p:sp>
       <p:sp>
         <p:nvSpPr>
           <p:cNvPr id="10" name="Text 5"/>
@@ -3343,7 +3587,7 @@
         </p:nvSpPr>
         <p:spPr>
           <a:xfrm>
-            <a:off x="1325880" y="1801368"/>
+            <a:off x="1325880" y="2055368"/>
             <a:ext cx="5596128" cy="530352"/>
           </a:xfrm>
           <a:prstGeom prst="rect">
@@ -3390,7 +3634,7 @@
         </p:blipFill>
         <p:spPr>
           <a:xfrm>
-            <a:off x="749808" y="2404872"/>
+            <a:off x="749808" y="2658872"/>
             <a:ext cx="192024" cy="192024"/>
           </a:xfrm>
           <a:prstGeom prst="rect">
@@ -3406,7 +3650,7 @@
         </p:nvSpPr>
         <p:spPr>
           <a:xfrm>
-            <a:off x="1042416" y="2377440"/>
+            <a:off x="1042416" y="2631440"/>
             <a:ext cx="5779008" cy="365760"/>
           </a:xfrm>
           <a:prstGeom prst="rect">
@@ -3453,7 +3697,7 @@
         </p:blipFill>
         <p:spPr>
           <a:xfrm>
-            <a:off x="749808" y="2770632"/>
+            <a:off x="749808" y="3024632"/>
             <a:ext cx="192024" cy="192024"/>
           </a:xfrm>
           <a:prstGeom prst="rect">
@@ -3469,7 +3713,7 @@
         </p:nvSpPr>
         <p:spPr>
           <a:xfrm>
-            <a:off x="1042416" y="2743200"/>
+            <a:off x="1042416" y="2997200"/>
             <a:ext cx="5779008" cy="365760"/>
           </a:xfrm>
           <a:prstGeom prst="rect">
@@ -3516,7 +3760,7 @@
         </p:blipFill>
         <p:spPr>
           <a:xfrm>
-            <a:off x="749808" y="3136392"/>
+            <a:off x="749808" y="3390392"/>
             <a:ext cx="192024" cy="192024"/>
           </a:xfrm>
           <a:prstGeom prst="rect">
@@ -3532,7 +3776,7 @@
         </p:nvSpPr>
         <p:spPr>
           <a:xfrm>
-            <a:off x="1042416" y="3108960"/>
+            <a:off x="1042416" y="3362960"/>
             <a:ext cx="5779008" cy="365760"/>
           </a:xfrm>
           <a:prstGeom prst="rect">
@@ -3579,7 +3823,7 @@
         </p:blipFill>
         <p:spPr>
           <a:xfrm>
-            <a:off x="749808" y="3502152"/>
+            <a:off x="749808" y="3756152"/>
             <a:ext cx="192024" cy="192024"/>
           </a:xfrm>
           <a:prstGeom prst="rect">
@@ -3595,7 +3839,7 @@
         </p:nvSpPr>
         <p:spPr>
           <a:xfrm>
-            <a:off x="1042416" y="3474720"/>
+            <a:off x="1042416" y="3728720"/>
             <a:ext cx="5779008" cy="365760"/>
           </a:xfrm>
           <a:prstGeom prst="rect">
@@ -3634,7 +3878,7 @@
         </p:nvSpPr>
         <p:spPr>
           <a:xfrm>
-            <a:off x="457200" y="4096512"/>
+            <a:off x="457200" y="4350512"/>
             <a:ext cx="6647688" cy="2322576"/>
           </a:xfrm>
           <a:prstGeom prst="roundRect">
@@ -3661,14 +3905,14 @@
       </p:sp>
       <p:sp>
         <p:nvSpPr>
-          <p:cNvPr id="61" name="Rounded Rectangle 60"/>
-          <p:cNvSpPr/>
-          <p:nvPr/>
-        </p:nvSpPr>
-        <p:spPr>
-          <a:xfrm>
-            <a:off x="457200" y="4096512"/>
-            <a:ext cx="6647688" cy="635000"/>
+          <p:cNvPr id="64" name="Rounded Rectangle 63"/>
+          <p:cNvSpPr/>
+          <p:nvPr/>
+        </p:nvSpPr>
+        <p:spPr>
+          <a:xfrm>
+            <a:off x="457200" y="4350512"/>
+            <a:ext cx="6647688" cy="660400"/>
           </a:xfrm>
           <a:prstGeom prst="roundRect">
             <a:avLst/>
@@ -3711,14 +3955,14 @@
         </p:nvSpPr>
         <p:spPr>
           <a:xfrm>
-            <a:off x="658368" y="4251960"/>
-            <a:ext cx="530352" cy="530352"/>
+            <a:off x="658368" y="4505960"/>
+            <a:ext cx="508000" cy="508000"/>
           </a:xfrm>
           <a:prstGeom prst="ellipse">
             <a:avLst/>
           </a:prstGeom>
           <a:solidFill>
-            <a:srgbClr val="C4321B"/>
+            <a:srgbClr val="FFFFFF"/>
           </a:solidFill>
           <a:ln>
             <a:noFill/>
@@ -3731,31 +3975,22 @@
             </a:outerShdw>
           </a:effectLst>
         </p:spPr>
-      </p:sp>
-      <p:pic>
-        <p:nvPicPr>
-          <p:cNvPr id="21" name="Image 7" descr="preencoded.png">    </p:cNvPr>
-          <p:cNvPicPr>
-            <a:picLocks noChangeAspect="1"/>
-          </p:cNvPicPr>
-          <p:nvPr/>
-        </p:nvPicPr>
-        <p:blipFill>
-          <a:blip r:embed="rId8"/>
-          <a:stretch>
-            <a:fillRect/>
-          </a:stretch>
-        </p:blipFill>
-        <p:spPr>
-          <a:xfrm>
-            <a:off x="785652" y="4379244"/>
-            <a:ext cx="275783" cy="275783"/>
-          </a:xfrm>
-          <a:prstGeom prst="rect">
-            <a:avLst/>
-          </a:prstGeom>
-        </p:spPr>
-      </p:pic>
+        <p:txBody>
+          <a:bodyPr wrap="none" anchor="ctr" lIns="0" rIns="0" tIns="0" bIns="0"/>
+          <a:p>
+            <a:pPr algn="ctr"/>
+            <a:r>
+              <a:rPr sz="2200" b="1">
+                <a:solidFill>
+                  <a:srgbClr val="C4321B"/>
+                </a:solidFill>
+                <a:latin typeface="Calibri"/>
+              </a:rPr>
+              <a:t>2</a:t>
+            </a:r>
+          </a:p>
+        </p:txBody>
+      </p:sp>
       <p:sp>
         <p:nvSpPr>
           <p:cNvPr id="22" name="Text 12"/>
@@ -3764,7 +3999,7 @@
         </p:nvSpPr>
         <p:spPr>
           <a:xfrm>
-            <a:off x="1325880" y="4251960"/>
+            <a:off x="1325880" y="4505960"/>
             <a:ext cx="5596128" cy="530352"/>
           </a:xfrm>
           <a:prstGeom prst="rect">
@@ -3811,7 +4046,7 @@
         </p:blipFill>
         <p:spPr>
           <a:xfrm>
-            <a:off x="749808" y="4855464"/>
+            <a:off x="749808" y="5109464"/>
             <a:ext cx="192024" cy="192024"/>
           </a:xfrm>
           <a:prstGeom prst="rect">
@@ -3827,7 +4062,7 @@
         </p:nvSpPr>
         <p:spPr>
           <a:xfrm>
-            <a:off x="1042416" y="4828032"/>
+            <a:off x="1042416" y="5082032"/>
             <a:ext cx="5779008" cy="365760"/>
           </a:xfrm>
           <a:prstGeom prst="rect">
@@ -3874,7 +4109,7 @@
         </p:blipFill>
         <p:spPr>
           <a:xfrm>
-            <a:off x="749808" y="5221224"/>
+            <a:off x="749808" y="5475224"/>
             <a:ext cx="192024" cy="192024"/>
           </a:xfrm>
           <a:prstGeom prst="rect">
@@ -3890,7 +4125,7 @@
         </p:nvSpPr>
         <p:spPr>
           <a:xfrm>
-            <a:off x="1042416" y="5193792"/>
+            <a:off x="1042416" y="5447792"/>
             <a:ext cx="5779008" cy="365760"/>
           </a:xfrm>
           <a:prstGeom prst="rect">
@@ -3937,7 +4172,7 @@
         </p:blipFill>
         <p:spPr>
           <a:xfrm>
-            <a:off x="749808" y="5586984"/>
+            <a:off x="749808" y="5840984"/>
             <a:ext cx="192024" cy="192024"/>
           </a:xfrm>
           <a:prstGeom prst="rect">
@@ -3953,7 +4188,7 @@
         </p:nvSpPr>
         <p:spPr>
           <a:xfrm>
-            <a:off x="1042416" y="5559552"/>
+            <a:off x="1042416" y="5813552"/>
             <a:ext cx="5779008" cy="365760"/>
           </a:xfrm>
           <a:prstGeom prst="rect">
@@ -4000,7 +4235,7 @@
         </p:blipFill>
         <p:spPr>
           <a:xfrm>
-            <a:off x="749808" y="5952744"/>
+            <a:off x="749808" y="6206744"/>
             <a:ext cx="192024" cy="192024"/>
           </a:xfrm>
           <a:prstGeom prst="rect">
@@ -4016,7 +4251,7 @@
         </p:nvSpPr>
         <p:spPr>
           <a:xfrm>
-            <a:off x="1042416" y="5925312"/>
+            <a:off x="1042416" y="6179312"/>
             <a:ext cx="5779008" cy="365760"/>
           </a:xfrm>
           <a:prstGeom prst="rect">
@@ -4055,7 +4290,7 @@
         </p:nvSpPr>
         <p:spPr>
           <a:xfrm>
-            <a:off x="457200" y="6547104"/>
+            <a:off x="457200" y="6801104"/>
             <a:ext cx="6647688" cy="2121408"/>
           </a:xfrm>
           <a:prstGeom prst="roundRect">
@@ -4082,14 +4317,14 @@
       </p:sp>
       <p:sp>
         <p:nvSpPr>
-          <p:cNvPr id="62" name="Rounded Rectangle 61"/>
-          <p:cNvSpPr/>
-          <p:nvPr/>
-        </p:nvSpPr>
-        <p:spPr>
-          <a:xfrm>
-            <a:off x="457200" y="6547104"/>
-            <a:ext cx="6647688" cy="635000"/>
+          <p:cNvPr id="65" name="Rounded Rectangle 64"/>
+          <p:cNvSpPr/>
+          <p:nvPr/>
+        </p:nvSpPr>
+        <p:spPr>
+          <a:xfrm>
+            <a:off x="457200" y="6801104"/>
+            <a:ext cx="6647688" cy="660400"/>
           </a:xfrm>
           <a:prstGeom prst="roundRect">
             <a:avLst/>
@@ -4132,14 +4367,14 @@
         </p:nvSpPr>
         <p:spPr>
           <a:xfrm>
-            <a:off x="658368" y="6702552"/>
-            <a:ext cx="530352" cy="530352"/>
+            <a:off x="658368" y="6956552"/>
+            <a:ext cx="508000" cy="508000"/>
           </a:xfrm>
           <a:prstGeom prst="ellipse">
             <a:avLst/>
           </a:prstGeom>
           <a:solidFill>
-            <a:srgbClr val="0B5E86"/>
+            <a:srgbClr val="FFFFFF"/>
           </a:solidFill>
           <a:ln>
             <a:noFill/>
@@ -4152,31 +4387,22 @@
             </a:outerShdw>
           </a:effectLst>
         </p:spPr>
-      </p:sp>
-      <p:pic>
-        <p:nvPicPr>
-          <p:cNvPr id="33" name="Image 12" descr="preencoded.png">    </p:cNvPr>
-          <p:cNvPicPr>
-            <a:picLocks noChangeAspect="1"/>
-          </p:cNvPicPr>
-          <p:nvPr/>
-        </p:nvPicPr>
-        <p:blipFill>
-          <a:blip r:embed="rId13"/>
-          <a:stretch>
-            <a:fillRect/>
-          </a:stretch>
-        </p:blipFill>
-        <p:spPr>
-          <a:xfrm>
-            <a:off x="785652" y="6829836"/>
-            <a:ext cx="275783" cy="275783"/>
-          </a:xfrm>
-          <a:prstGeom prst="rect">
-            <a:avLst/>
-          </a:prstGeom>
-        </p:spPr>
-      </p:pic>
+        <p:txBody>
+          <a:bodyPr wrap="none" anchor="ctr" lIns="0" rIns="0" tIns="0" bIns="0"/>
+          <a:p>
+            <a:pPr algn="ctr"/>
+            <a:r>
+              <a:rPr sz="2200" b="1">
+                <a:solidFill>
+                  <a:srgbClr val="0B5E86"/>
+                </a:solidFill>
+                <a:latin typeface="Calibri"/>
+              </a:rPr>
+              <a:t>3</a:t>
+            </a:r>
+          </a:p>
+        </p:txBody>
+      </p:sp>
       <p:sp>
         <p:nvSpPr>
           <p:cNvPr id="34" name="Text 19"/>
@@ -4185,7 +4411,7 @@
         </p:nvSpPr>
         <p:spPr>
           <a:xfrm>
-            <a:off x="1325880" y="6702552"/>
+            <a:off x="1325880" y="6956552"/>
             <a:ext cx="5596128" cy="530352"/>
           </a:xfrm>
           <a:prstGeom prst="rect">
@@ -4232,7 +4458,7 @@
         </p:blipFill>
         <p:spPr>
           <a:xfrm>
-            <a:off x="731520" y="7306056"/>
+            <a:off x="731520" y="7560056"/>
             <a:ext cx="173736" cy="173736"/>
           </a:xfrm>
           <a:prstGeom prst="rect">
@@ -4248,7 +4474,7 @@
         </p:nvSpPr>
         <p:spPr>
           <a:xfrm>
-            <a:off x="987552" y="7278624"/>
+            <a:off x="987552" y="7532624"/>
             <a:ext cx="2729484" cy="420624"/>
           </a:xfrm>
           <a:prstGeom prst="rect">
@@ -4295,7 +4521,7 @@
         </p:blipFill>
         <p:spPr>
           <a:xfrm>
-            <a:off x="731520" y="7726680"/>
+            <a:off x="731520" y="7980680"/>
             <a:ext cx="173736" cy="173736"/>
           </a:xfrm>
           <a:prstGeom prst="rect">
@@ -4311,7 +4537,7 @@
         </p:nvSpPr>
         <p:spPr>
           <a:xfrm>
-            <a:off x="987552" y="7699248"/>
+            <a:off x="987552" y="7953248"/>
             <a:ext cx="2729484" cy="420624"/>
           </a:xfrm>
           <a:prstGeom prst="rect">
@@ -4358,7 +4584,7 @@
         </p:blipFill>
         <p:spPr>
           <a:xfrm>
-            <a:off x="731520" y="8147304"/>
+            <a:off x="731520" y="8401304"/>
             <a:ext cx="173736" cy="173736"/>
           </a:xfrm>
           <a:prstGeom prst="rect">
@@ -4374,7 +4600,7 @@
         </p:nvSpPr>
         <p:spPr>
           <a:xfrm>
-            <a:off x="987552" y="8119872"/>
+            <a:off x="987552" y="8373872"/>
             <a:ext cx="2729484" cy="420624"/>
           </a:xfrm>
           <a:prstGeom prst="rect">
@@ -4421,7 +4647,7 @@
         </p:blipFill>
         <p:spPr>
           <a:xfrm>
-            <a:off x="3826764" y="7306056"/>
+            <a:off x="3826764" y="7560056"/>
             <a:ext cx="173736" cy="173736"/>
           </a:xfrm>
           <a:prstGeom prst="rect">
@@ -4437,7 +4663,7 @@
         </p:nvSpPr>
         <p:spPr>
           <a:xfrm>
-            <a:off x="4082796" y="7278624"/>
+            <a:off x="4082796" y="7532624"/>
             <a:ext cx="2729484" cy="420624"/>
           </a:xfrm>
           <a:prstGeom prst="rect">
@@ -4484,7 +4710,7 @@
         </p:blipFill>
         <p:spPr>
           <a:xfrm>
-            <a:off x="3826764" y="7726680"/>
+            <a:off x="3826764" y="7980680"/>
             <a:ext cx="173736" cy="173736"/>
           </a:xfrm>
           <a:prstGeom prst="rect">
@@ -4500,7 +4726,7 @@
         </p:nvSpPr>
         <p:spPr>
           <a:xfrm>
-            <a:off x="4082796" y="7699248"/>
+            <a:off x="4082796" y="7953248"/>
             <a:ext cx="2729484" cy="420624"/>
           </a:xfrm>
           <a:prstGeom prst="rect">
@@ -4547,7 +4773,7 @@
         </p:blipFill>
         <p:spPr>
           <a:xfrm>
-            <a:off x="3826764" y="8147304"/>
+            <a:off x="3826764" y="8401304"/>
             <a:ext cx="173736" cy="173736"/>
           </a:xfrm>
           <a:prstGeom prst="rect">
@@ -4563,7 +4789,7 @@
         </p:nvSpPr>
         <p:spPr>
           <a:xfrm>
-            <a:off x="4082796" y="8119872"/>
+            <a:off x="4082796" y="8373872"/>
             <a:ext cx="2729484" cy="420624"/>
           </a:xfrm>
           <a:prstGeom prst="rect">
@@ -4602,7 +4828,7 @@
         </p:nvSpPr>
         <p:spPr>
           <a:xfrm>
-            <a:off x="457200" y="8796528"/>
+            <a:off x="457200" y="9050528"/>
             <a:ext cx="6647688" cy="274320"/>
           </a:xfrm>
           <a:prstGeom prst="rect">
@@ -4641,7 +4867,7 @@
         </p:nvSpPr>
         <p:spPr>
           <a:xfrm>
-            <a:off x="457200" y="9107424"/>
+            <a:off x="457200" y="9361424"/>
             <a:ext cx="2093976" cy="676656"/>
           </a:xfrm>
           <a:prstGeom prst="roundRect">
@@ -4670,7 +4896,7 @@
         </p:nvSpPr>
         <p:spPr>
           <a:xfrm>
-            <a:off x="548640" y="9107424"/>
+            <a:off x="548640" y="9361424"/>
             <a:ext cx="841248" cy="676656"/>
           </a:xfrm>
           <a:prstGeom prst="rect">
@@ -4709,7 +4935,7 @@
         </p:nvSpPr>
         <p:spPr>
           <a:xfrm>
-            <a:off x="1353312" y="9107424"/>
+            <a:off x="1353312" y="9361424"/>
             <a:ext cx="1124712" cy="676656"/>
           </a:xfrm>
           <a:prstGeom prst="rect">
@@ -4748,7 +4974,7 @@
         </p:nvSpPr>
         <p:spPr>
           <a:xfrm>
-            <a:off x="2734056" y="9107424"/>
+            <a:off x="2734056" y="9361424"/>
             <a:ext cx="2093976" cy="676656"/>
           </a:xfrm>
           <a:prstGeom prst="roundRect">
@@ -4777,7 +5003,7 @@
         </p:nvSpPr>
         <p:spPr>
           <a:xfrm>
-            <a:off x="2825496" y="9107424"/>
+            <a:off x="2825496" y="9361424"/>
             <a:ext cx="841248" cy="676656"/>
           </a:xfrm>
           <a:prstGeom prst="rect">
@@ -4816,7 +5042,7 @@
         </p:nvSpPr>
         <p:spPr>
           <a:xfrm>
-            <a:off x="3630168" y="9107424"/>
+            <a:off x="3630168" y="9361424"/>
             <a:ext cx="1124712" cy="676656"/>
           </a:xfrm>
           <a:prstGeom prst="rect">
@@ -4855,7 +5081,7 @@
         </p:nvSpPr>
         <p:spPr>
           <a:xfrm>
-            <a:off x="5010912" y="9107424"/>
+            <a:off x="5010912" y="9361424"/>
             <a:ext cx="2093976" cy="676656"/>
           </a:xfrm>
           <a:prstGeom prst="roundRect">
@@ -4884,7 +5110,7 @@
         </p:nvSpPr>
         <p:spPr>
           <a:xfrm>
-            <a:off x="5102352" y="9107424"/>
+            <a:off x="5102352" y="9361424"/>
             <a:ext cx="841248" cy="676656"/>
           </a:xfrm>
           <a:prstGeom prst="rect">
@@ -4923,7 +5149,7 @@
         </p:nvSpPr>
         <p:spPr>
           <a:xfrm>
-            <a:off x="5907024" y="9107424"/>
+            <a:off x="5907024" y="9361424"/>
             <a:ext cx="1124712" cy="676656"/>
           </a:xfrm>
           <a:prstGeom prst="rect">
@@ -4962,7 +5188,7 @@
         </p:nvSpPr>
         <p:spPr>
           <a:xfrm>
-            <a:off x="457200" y="9857232"/>
+            <a:off x="457200" y="10111232"/>
             <a:ext cx="6647688" cy="512064"/>
           </a:xfrm>
           <a:prstGeom prst="roundRect">
@@ -4991,7 +5217,7 @@
         </p:nvSpPr>
         <p:spPr>
           <a:xfrm>
-            <a:off x="640080" y="9857232"/>
+            <a:off x="640080" y="10111232"/>
             <a:ext cx="6281928" cy="512064"/>
           </a:xfrm>
           <a:prstGeom prst="rect">
@@ -5024,20 +5250,20 @@
       </p:sp>
       <p:sp>
         <p:nvSpPr>
-          <p:cNvPr id="59" name="Rectangle 58"/>
-          <p:cNvSpPr/>
-          <p:nvPr/>
-        </p:nvSpPr>
-        <p:spPr>
-          <a:xfrm>
-            <a:off x="0" y="0"/>
-            <a:ext cx="7562088" cy="88900"/>
+          <p:cNvPr id="60" name="Rectangle 59"/>
+          <p:cNvSpPr/>
+          <p:nvPr/>
+        </p:nvSpPr>
+        <p:spPr>
+          <a:xfrm>
+            <a:off x="0" y="1778000"/>
+            <a:ext cx="7562088" cy="63500"/>
           </a:xfrm>
           <a:prstGeom prst="rect">
             <a:avLst/>
           </a:prstGeom>
           <a:solidFill>
-            <a:srgbClr val="0E3A54"/>
+            <a:srgbClr val="FDB515"/>
           </a:solidFill>
           <a:ln>
             <a:noFill/>

</xml_diff>